<commit_message>
docs: add project README, refresh deck and report from verified state
Implementation status reflects the tested build, the worked budget
example uses the actual Manali itinerary fees, and the deck picks up the
final diagram renders.

Co-Authored-By: Claude Fable 5.1 <noreply@anthropic.com>
</commit_message>
<xml_diff>
--- a/docs/Smart_Trip_Planner_Presentation1.pptx
+++ b/docs/Smart_Trip_Planner_Presentation1.pptx
@@ -2202,7 +2202,7 @@
           <a:p>
             <a:r>
               <a:rPr lang="en-US" dirty="0"/>
-              <a:t>[Hardik] 10 of 14 planned modules are complete, about 71 percent, which is above the 50 percent asked for Presentation-1. The whole main flow works end to end: browse, plan, preview, login, save, manage. What remains is listed as in progress; mention each in one line and say it is planned for the next phase. Then hand over to the demo.</a:t>
+              <a:t>[Hardik] 12 of 14 planned modules are complete, about 86 percent, which is above the 50 percent asked for Presentation-1. The whole main flow works end to end: browse, plan, preview, login, save, manage. What remains is listed as in progress; mention each in one line and say it is planned for the next phase. Then hand over to the demo.</a:t>
             </a:r>
             <a:endParaRPr lang="en-US" dirty="0"/>
           </a:p>
@@ -32886,7 +32886,7 @@
                 <a:ea typeface="Georgia" pitchFamily="34" charset="-122"/>
                 <a:cs typeface="Georgia" pitchFamily="34" charset="-120"/>
               </a:rPr>
-              <a:t>71%</a:t>
+              <a:t>86%</a:t>
             </a:r>
             <a:endParaRPr lang="en-US" sz="5400" dirty="0"/>
           </a:p>
@@ -32925,7 +32925,7 @@
                 <a:ea typeface="Arial" pitchFamily="34" charset="-122"/>
                 <a:cs typeface="Arial" pitchFamily="34" charset="-120"/>
               </a:rPr>
-              <a:t>10 of 14 modules complete</a:t>
+              <a:t>12 of 14 modules complete</a:t>
             </a:r>
             <a:endParaRPr lang="en-US" sz="1350" dirty="0"/>
           </a:p>
@@ -33803,7 +33803,7 @@
                 <a:ea typeface="Arial" pitchFamily="34" charset="-122"/>
                 <a:cs typeface="Arial" pitchFamily="34" charset="-120"/>
               </a:rPr>
-              <a:t>Google Places / Distance providers with fallback</a:t>
+              <a:t>Google Places / Distance providers — live-key testing</a:t>
             </a:r>
             <a:endParaRPr lang="en-US" sz="1150" dirty="0"/>
           </a:p>
@@ -33954,14 +33954,9 @@
             </a:avLst>
           </a:prstGeom>
           <a:solidFill>
-            <a:srgbClr val="F6F1E7"/>
+            <a:srgbClr val="1F2A33"/>
           </a:solidFill>
-          <a:ln w="12700">
-            <a:solidFill>
-              <a:srgbClr val="B4532A"/>
-            </a:solidFill>
-            <a:prstDash val="solid"/>
-          </a:ln>
+          <a:ln/>
         </p:spPr>
       </p:sp>
       <p:sp>
@@ -33991,13 +33986,13 @@
             <a:r>
               <a:rPr lang="en-US" sz="850" b="1" spc="100" kern="0" dirty="0">
                 <a:solidFill>
-                  <a:srgbClr val="B4532A"/>
+                  <a:srgbClr val="F6F1E7"/>
                 </a:solidFill>
                 <a:latin typeface="Arial" pitchFamily="34" charset="0"/>
                 <a:ea typeface="Arial" pitchFamily="34" charset="-122"/>
                 <a:cs typeface="Arial" pitchFamily="34" charset="-120"/>
               </a:rPr>
-              <a:t>IN PROGRESS</a:t>
+              <a:t>DONE</a:t>
             </a:r>
             <a:endParaRPr lang="en-US" sz="850" dirty="0"/>
           </a:p>
@@ -34613,14 +34608,9 @@
             </a:avLst>
           </a:prstGeom>
           <a:solidFill>
-            <a:srgbClr val="F6F1E7"/>
+            <a:srgbClr val="1F2A33"/>
           </a:solidFill>
-          <a:ln w="12700">
-            <a:solidFill>
-              <a:srgbClr val="B4532A"/>
-            </a:solidFill>
-            <a:prstDash val="solid"/>
-          </a:ln>
+          <a:ln/>
         </p:spPr>
       </p:sp>
       <p:sp>
@@ -34650,13 +34640,13 @@
             <a:r>
               <a:rPr lang="en-US" sz="850" b="1" spc="100" kern="0" dirty="0">
                 <a:solidFill>
-                  <a:srgbClr val="B4532A"/>
+                  <a:srgbClr val="F6F1E7"/>
                 </a:solidFill>
                 <a:latin typeface="Arial" pitchFamily="34" charset="0"/>
                 <a:ea typeface="Arial" pitchFamily="34" charset="-122"/>
                 <a:cs typeface="Arial" pitchFamily="34" charset="-120"/>
               </a:rPr>
-              <a:t>IN PROGRESS</a:t>
+              <a:t>DONE</a:t>
             </a:r>
             <a:endParaRPr lang="en-US" sz="850" dirty="0"/>
           </a:p>
@@ -34718,7 +34708,7 @@
                 <a:ea typeface="Arial" pitchFamily="34" charset="-122"/>
                 <a:cs typeface="Arial" pitchFamily="34" charset="-120"/>
               </a:rPr>
-              <a:t>Responsive + accessibility polish</a:t>
+              <a:t>Accessibility audit + cross-browser testing</a:t>
             </a:r>
             <a:endParaRPr lang="en-US" sz="1150" dirty="0"/>
           </a:p>

</xml_diff>

<commit_message>
docs: data dictionary in the prescribed format with sample records
Field name / Datatype / Len / Constrains / Description tables, five
records per collection, OSM providers in the class, use case and
architecture diagrams, deck and README updated to match.

Co-Authored-By: Claude Fable 5.1 <noreply@anthropic.com>
</commit_message>
<xml_diff>
--- a/docs/Smart_Trip_Planner_Presentation1.pptx
+++ b/docs/Smart_Trip_Planner_Presentation1.pptx
@@ -706,7 +706,7 @@
           <a:p>
             <a:r>
               <a:rPr lang="en-US" dirty="0"/>
-              <a:t>[Hardik] The stack is MERN with JavaScript end to end. On the client React 18 with Vite and React Router, and hand-written CSS with design tokens, no UI kit. On the server Node 20 and Express, with Zod for validation and JWT plus bcrypt for security. MongoDB 7 with Mongoose, run through Docker Compose. Google Places and Distance Matrix are optional. Vitest and Supertest for tests, Git for version control.</a:t>
+              <a:t>[Hardik] The stack is MERN with JavaScript end to end. On the client React 18 with Vite and React Router, and hand-written CSS with design tokens, no UI kit. On the server Node 20 and Express, with Zod for validation and JWT plus bcrypt for security. MongoDB 7 with Mongoose, run through Docker Compose. OpenStreetMap Overpass and OSRM are the free map services; Google Places and Distance Matrix are optional. Vitest and Supertest for tests, Git for version control.</a:t>
             </a:r>
             <a:endParaRPr lang="en-US" dirty="0"/>
           </a:p>
@@ -794,7 +794,7 @@
           <a:p>
             <a:r>
               <a:rPr lang="en-US" dirty="0"/>
-              <a:t>[Udit] Assumptions are what the estimate takes for granted: two travellers share a room, nights are days minus one, costs are daily averages per tier, and without Google the road distance is straight-line times 1.3 at 25 km per hour. Constraints are hard limits in the code: twelve destinations, up to fourteen days, up to twelve travellers, a four-second timeout on Google calls, and twenty auth requests per fifteen minutes per IP.</a:t>
+              <a:t>[Udit] Assumptions are what the estimate takes for granted: two travellers share a room, nights are days minus one, costs are daily averages per tier, and with the local provider the road distance is straight-line times 1.3 at 25 km per hour. Constraints are hard limits in the code: twelve destinations, up to fourteen days, up to twelve travellers, a four-second timeout on external route calls, and twenty auth requests per fifteen minutes per IP.</a:t>
             </a:r>
             <a:endParaRPr lang="en-US" dirty="0"/>
           </a:p>
@@ -1146,7 +1146,7 @@
           <a:p>
             <a:r>
               <a:rPr lang="en-US" dirty="0"/>
-              <a:t>[Vraj] Two human actors. A guest can browse destinations, view details, discover nearby places and generate a plan preview. A registered traveller does all of that and also saves trips, views My Trips, updates notes and status, and deletes. Generating a plan always includes building the itinerary and estimating the budget. The Google services appear as an external, optional actor.</a:t>
+              <a:t>[Vraj] Two human actors. A guest can browse destinations, view details, discover nearby places and generate a plan preview. A registered traveller does all of that and also saves trips, views My Trips, updates notes and status, and deletes. Generating a plan always includes building the itinerary and estimating the budget. The map services appear as external, optional actors.</a:t>
             </a:r>
             <a:endParaRPr lang="en-US" dirty="0"/>
           </a:p>
@@ -2202,7 +2202,7 @@
           <a:p>
             <a:r>
               <a:rPr lang="en-US" dirty="0"/>
-              <a:t>[Hardik] 12 of 14 planned modules are complete, about 86 percent, which is above the 50 percent asked for Presentation-1. The whole main flow works end to end: browse, plan, preview, login, save, manage. What remains is listed as in progress; mention each in one line and say it is planned for the next phase. Then hand over to the demo.</a:t>
+              <a:t>[Hardik] 13 of 15 planned modules are complete, about 87 percent, which is above the 50 percent asked for Presentation-1. The whole main flow works end to end: browse, plan, preview, login, save, manage. What remains is listed as in progress; mention each in one line and say it is planned for the next phase. Then hand over to the demo.</a:t>
             </a:r>
             <a:endParaRPr lang="en-US" dirty="0"/>
           </a:p>
@@ -2906,7 +2906,7 @@
           <a:p>
             <a:r>
               <a:rPr lang="en-US" dirty="0"/>
-              <a:t>[Udit] Three tiers. The React client talks only to our REST API under /api/v1; the API is layered as routes, controllers and services; MongoDB holds four collections. The six blocks below are the services where the logic lives. Controllers only handle HTTP, so itinerary and budget are pure functions that we can unit test. Providers hide where distance and places come from: local by default, Google when a key is configured.</a:t>
+              <a:t>[Udit] Three tiers. The React client talks only to our REST API under /api/v1; the API is layered as routes, controllers and services; MongoDB holds four collections. The six blocks below are the services where the logic lives. Controllers only handle HTTP, so itinerary and budget are pure functions that we can unit test. Providers hide where distance and places come from: local by default, OpenStreetMap/OSRM or Google by configuration.</a:t>
             </a:r>
             <a:endParaRPr lang="en-US" dirty="0"/>
           </a:p>
@@ -2994,7 +2994,7 @@
           <a:p>
             <a:r>
               <a:rPr lang="en-US" dirty="0"/>
-              <a:t>[Udit] Same three tiers, now as deployed for the demo: Vite dev server on 5173 proxies /api to Express on 4100, MongoDB 7 runs in Docker on 27017. Follow one request: page, apiClient, route, validate middleware, controller, service, model. If a Google key is set the providers call Places and Distance Matrix with a 4-second timeout, otherwise, or on any failure, the local provider answers.</a:t>
+              <a:t>[Udit] Same three tiers, now as deployed for the demo: Vite dev server on 5173 proxies /api to Express on 4100, MongoDB 7 runs in Docker on 27017. Follow one request: page, apiClient, route, validate middleware, controller, service, model. When the provider is set to OpenStreetMap or Google the providers call the external places and distance services with a timeout, otherwise, or on any failure, the local provider answers.</a:t>
             </a:r>
             <a:endParaRPr lang="en-US" dirty="0"/>
           </a:p>
@@ -7029,7 +7029,7 @@
                           <a:ea typeface="Arial" pitchFamily="34" charset="-122"/>
                           <a:cs typeface="Arial" pitchFamily="34" charset="-120"/>
                         </a:rPr>
-                        <a:t>Google Places API, Distance Matrix API</a:t>
+                        <a:t>Overpass (OpenStreetMap), OSRM; optional Google Places, Distance Matrix</a:t>
                       </a:r>
                       <a:endParaRPr lang="en-US" sz="1250" dirty="0">
                         <a:latin typeface="Arial" charset="0"/>
@@ -7079,7 +7079,7 @@
                           <a:ea typeface="Arial" pitchFamily="34" charset="-122"/>
                           <a:cs typeface="Arial" pitchFamily="34" charset="-120"/>
                         </a:rPr>
-                        <a:t>Optional discovery and road distance; local fallback</a:t>
+                        <a:t>Place discovery and road distance; local fallback</a:t>
                       </a:r>
                       <a:endParaRPr lang="en-US" sz="1250" dirty="0">
                         <a:latin typeface="Arial" charset="0"/>
@@ -8455,7 +8455,7 @@
                 <a:ea typeface="Arial" pitchFamily="34" charset="-122"/>
                 <a:cs typeface="Arial" pitchFamily="34" charset="-120"/>
               </a:rPr>
-              <a:t>Google API timeout, then local fallback</a:t>
+              <a:t>External API timeout, then local fallback</a:t>
             </a:r>
             <a:endParaRPr lang="en-US" sz="1150" dirty="0"/>
           </a:p>
@@ -13663,7 +13663,7 @@
                 <a:ea typeface="Arial" pitchFamily="34" charset="-122"/>
                 <a:cs typeface="Arial" pitchFamily="34" charset="-120"/>
               </a:rPr>
-              <a:t>Save trip extends Plan trip only when logged in. The two Google APIs are external actors.</a:t>
+              <a:t>Save trip extends Plan trip only when logged in. The Places and Route APIs are external actors.</a:t>
             </a:r>
             <a:endParaRPr lang="en-US" sz="1400" dirty="0"/>
           </a:p>
@@ -13900,8 +13900,8 @@
         </p:blipFill>
         <p:spPr>
           <a:xfrm>
-            <a:off x="2317373" y="1453896"/>
-            <a:ext cx="3120547" cy="4206240"/>
+            <a:off x="2297680" y="1453896"/>
+            <a:ext cx="3159931" cy="4206240"/>
           </a:xfrm>
           <a:prstGeom prst="rect">
             <a:avLst/>
@@ -13916,7 +13916,7 @@
         </p:nvSpPr>
         <p:spPr>
           <a:xfrm>
-            <a:off x="5597940" y="1600200"/>
+            <a:off x="5617632" y="1600200"/>
             <a:ext cx="0" cy="3913632"/>
           </a:xfrm>
           <a:prstGeom prst="line">
@@ -13947,7 +13947,7 @@
         </p:blipFill>
         <p:spPr>
           <a:xfrm>
-            <a:off x="5757960" y="1453896"/>
+            <a:off x="5777652" y="1453896"/>
             <a:ext cx="4116363" cy="4206240"/>
           </a:xfrm>
           <a:prstGeom prst="rect">
@@ -14836,8 +14836,8 @@
         </p:blipFill>
         <p:spPr>
           <a:xfrm>
-            <a:off x="813816" y="1523686"/>
-            <a:ext cx="4745475" cy="4066660"/>
+            <a:off x="813816" y="1568416"/>
+            <a:ext cx="4866435" cy="3977199"/>
           </a:xfrm>
           <a:prstGeom prst="rect">
             <a:avLst/>
@@ -14852,7 +14852,7 @@
         </p:nvSpPr>
         <p:spPr>
           <a:xfrm>
-            <a:off x="5719311" y="1600200"/>
+            <a:off x="5840271" y="1600200"/>
             <a:ext cx="0" cy="3913632"/>
           </a:xfrm>
           <a:prstGeom prst="line">
@@ -14883,8 +14883,8 @@
         </p:blipFill>
         <p:spPr>
           <a:xfrm>
-            <a:off x="5879331" y="1523686"/>
-            <a:ext cx="5498549" cy="4066660"/>
+            <a:off x="6000291" y="1568416"/>
+            <a:ext cx="5377588" cy="3977199"/>
           </a:xfrm>
           <a:prstGeom prst="rect">
             <a:avLst/>
@@ -16972,11 +16972,11 @@
         <p:spPr>
           <a:xfrm>
             <a:off x="4800600" y="1325880"/>
-            <a:ext cx="6705295" cy="2901551"/>
+            <a:ext cx="6705295" cy="3273552"/>
           </a:xfrm>
           <a:prstGeom prst="roundRect">
             <a:avLst>
-              <a:gd name="adj" fmla="val 1891"/>
+              <a:gd name="adj" fmla="val 1676"/>
             </a:avLst>
           </a:prstGeom>
           <a:solidFill>
@@ -17006,8 +17006,8 @@
         </p:blipFill>
         <p:spPr>
           <a:xfrm>
-            <a:off x="4928616" y="1453896"/>
-            <a:ext cx="6449263" cy="2645519"/>
+            <a:off x="5309931" y="1453896"/>
+            <a:ext cx="5686634" cy="3017520"/>
           </a:xfrm>
           <a:prstGeom prst="rect">
             <a:avLst/>
@@ -17022,7 +17022,7 @@
         </p:nvSpPr>
         <p:spPr>
           <a:xfrm>
-            <a:off x="4800600" y="4428599"/>
+            <a:off x="4800600" y="4800600"/>
             <a:ext cx="6705295" cy="548640"/>
           </a:xfrm>
           <a:prstGeom prst="rect">
@@ -17061,7 +17061,7 @@
         </p:nvSpPr>
         <p:spPr>
           <a:xfrm>
-            <a:off x="4800600" y="5114399"/>
+            <a:off x="4800600" y="5486400"/>
             <a:ext cx="274320" cy="274320"/>
           </a:xfrm>
           <a:prstGeom prst="ellipse">
@@ -17081,7 +17081,7 @@
         </p:nvSpPr>
         <p:spPr>
           <a:xfrm>
-            <a:off x="4800600" y="5114399"/>
+            <a:off x="4800600" y="5486400"/>
             <a:ext cx="274320" cy="274320"/>
           </a:xfrm>
           <a:prstGeom prst="rect">
@@ -17120,7 +17120,7 @@
         </p:nvSpPr>
         <p:spPr>
           <a:xfrm>
-            <a:off x="5184648" y="5105255"/>
+            <a:off x="5184648" y="5477256"/>
             <a:ext cx="1668170" cy="822960"/>
           </a:xfrm>
           <a:prstGeom prst="rect">
@@ -17159,7 +17159,7 @@
         </p:nvSpPr>
         <p:spPr>
           <a:xfrm>
-            <a:off x="7127138" y="5114399"/>
+            <a:off x="7127138" y="5486400"/>
             <a:ext cx="274320" cy="274320"/>
           </a:xfrm>
           <a:prstGeom prst="ellipse">
@@ -17179,7 +17179,7 @@
         </p:nvSpPr>
         <p:spPr>
           <a:xfrm>
-            <a:off x="7127138" y="5114399"/>
+            <a:off x="7127138" y="5486400"/>
             <a:ext cx="274320" cy="274320"/>
           </a:xfrm>
           <a:prstGeom prst="rect">
@@ -17218,7 +17218,7 @@
         </p:nvSpPr>
         <p:spPr>
           <a:xfrm>
-            <a:off x="7511186" y="5105255"/>
+            <a:off x="7511186" y="5477256"/>
             <a:ext cx="1668170" cy="822960"/>
           </a:xfrm>
           <a:prstGeom prst="rect">
@@ -17257,7 +17257,7 @@
         </p:nvSpPr>
         <p:spPr>
           <a:xfrm>
-            <a:off x="9453677" y="5114399"/>
+            <a:off x="9453677" y="5486400"/>
             <a:ext cx="274320" cy="274320"/>
           </a:xfrm>
           <a:prstGeom prst="ellipse">
@@ -17277,7 +17277,7 @@
         </p:nvSpPr>
         <p:spPr>
           <a:xfrm>
-            <a:off x="9453677" y="5114399"/>
+            <a:off x="9453677" y="5486400"/>
             <a:ext cx="274320" cy="274320"/>
           </a:xfrm>
           <a:prstGeom prst="rect">
@@ -17316,7 +17316,7 @@
         </p:nvSpPr>
         <p:spPr>
           <a:xfrm>
-            <a:off x="9837725" y="5105255"/>
+            <a:off x="9837725" y="5477256"/>
             <a:ext cx="1668170" cy="822960"/>
           </a:xfrm>
           <a:prstGeom prst="rect">
@@ -17341,7 +17341,7 @@
                 <a:ea typeface="Arial" pitchFamily="34" charset="-122"/>
                 <a:cs typeface="Arial" pitchFamily="34" charset="-120"/>
               </a:rPr>
-              <a:t>Route and Places providers are interfaces; Google implementations fall back to local.</a:t>
+              <a:t>Route and Places providers are interfaces; OpenStreetMap and Google implementations fall back to local.</a:t>
             </a:r>
             <a:endParaRPr lang="en-US" sz="1150" dirty="0"/>
           </a:p>
@@ -17581,7 +17581,7 @@
                           <a:ea typeface="Arial" pitchFamily="34" charset="-122"/>
                           <a:cs typeface="Arial" pitchFamily="34" charset="-120"/>
                         </a:rPr>
-                        <a:t>Field</a:t>
+                        <a:t>Field name</a:t>
                       </a:r>
                       <a:endParaRPr lang="en-US" sz="1200" dirty="0">
                         <a:latin typeface="Arial" charset="0"/>
@@ -17625,7 +17625,7 @@
                           <a:ea typeface="Arial" pitchFamily="34" charset="-122"/>
                           <a:cs typeface="Arial" pitchFamily="34" charset="-120"/>
                         </a:rPr>
-                        <a:t>Type</a:t>
+                        <a:t>Datatype</a:t>
                       </a:r>
                       <a:endParaRPr lang="en-US" sz="1200" dirty="0">
                         <a:latin typeface="Arial" charset="0"/>
@@ -17669,7 +17669,7 @@
                           <a:ea typeface="Arial" pitchFamily="34" charset="-122"/>
                           <a:cs typeface="Arial" pitchFamily="34" charset="-120"/>
                         </a:rPr>
-                        <a:t>Constraints</a:t>
+                        <a:t>Constrains</a:t>
                       </a:r>
                       <a:endParaRPr lang="en-US" sz="1200" dirty="0">
                         <a:latin typeface="Arial" charset="0"/>
@@ -19661,7 +19661,7 @@
                           <a:ea typeface="Arial" pitchFamily="34" charset="-122"/>
                           <a:cs typeface="Arial" pitchFamily="34" charset="-120"/>
                         </a:rPr>
-                        <a:t>Field</a:t>
+                        <a:t>Field name</a:t>
                       </a:r>
                       <a:endParaRPr lang="en-US" sz="1150" dirty="0">
                         <a:latin typeface="Arial" charset="0"/>
@@ -19705,7 +19705,7 @@
                           <a:ea typeface="Arial" pitchFamily="34" charset="-122"/>
                           <a:cs typeface="Arial" pitchFamily="34" charset="-120"/>
                         </a:rPr>
-                        <a:t>Type</a:t>
+                        <a:t>Datatype</a:t>
                       </a:r>
                       <a:endParaRPr lang="en-US" sz="1150" dirty="0">
                         <a:latin typeface="Arial" charset="0"/>
@@ -19749,7 +19749,7 @@
                           <a:ea typeface="Arial" pitchFamily="34" charset="-122"/>
                           <a:cs typeface="Arial" pitchFamily="34" charset="-120"/>
                         </a:rPr>
-                        <a:t>Constraints</a:t>
+                        <a:t>Constrains</a:t>
                       </a:r>
                       <a:endParaRPr lang="en-US" sz="1150" dirty="0">
                         <a:latin typeface="Arial" charset="0"/>
@@ -22887,7 +22887,7 @@
                           <a:ea typeface="Arial" pitchFamily="34" charset="-122"/>
                           <a:cs typeface="Arial" pitchFamily="34" charset="-120"/>
                         </a:rPr>
-                        <a:t>Field</a:t>
+                        <a:t>Field name</a:t>
                       </a:r>
                       <a:endParaRPr lang="en-US" sz="1200" dirty="0">
                         <a:latin typeface="Arial" charset="0"/>
@@ -22931,7 +22931,7 @@
                           <a:ea typeface="Arial" pitchFamily="34" charset="-122"/>
                           <a:cs typeface="Arial" pitchFamily="34" charset="-120"/>
                         </a:rPr>
-                        <a:t>Type</a:t>
+                        <a:t>Datatype</a:t>
                       </a:r>
                       <a:endParaRPr lang="en-US" sz="1200" dirty="0">
                         <a:latin typeface="Arial" charset="0"/>
@@ -22975,7 +22975,7 @@
                           <a:ea typeface="Arial" pitchFamily="34" charset="-122"/>
                           <a:cs typeface="Arial" pitchFamily="34" charset="-120"/>
                         </a:rPr>
-                        <a:t>Constraints</a:t>
+                        <a:t>Constrains</a:t>
                       </a:r>
                       <a:endParaRPr lang="en-US" sz="1200" dirty="0">
                         <a:latin typeface="Arial" charset="0"/>
@@ -25507,7 +25507,7 @@
                           <a:ea typeface="Arial" pitchFamily="34" charset="-122"/>
                           <a:cs typeface="Arial" pitchFamily="34" charset="-120"/>
                         </a:rPr>
-                        <a:t>Field</a:t>
+                        <a:t>Field name</a:t>
                       </a:r>
                       <a:endParaRPr lang="en-US" sz="1150" dirty="0">
                         <a:latin typeface="Arial" charset="0"/>
@@ -25551,7 +25551,7 @@
                           <a:ea typeface="Arial" pitchFamily="34" charset="-122"/>
                           <a:cs typeface="Arial" pitchFamily="34" charset="-120"/>
                         </a:rPr>
-                        <a:t>Type</a:t>
+                        <a:t>Datatype</a:t>
                       </a:r>
                       <a:endParaRPr lang="en-US" sz="1150" dirty="0">
                         <a:latin typeface="Arial" charset="0"/>
@@ -25595,7 +25595,7 @@
                           <a:ea typeface="Arial" pitchFamily="34" charset="-122"/>
                           <a:cs typeface="Arial" pitchFamily="34" charset="-120"/>
                         </a:rPr>
-                        <a:t>Constraints</a:t>
+                        <a:t>Constrains</a:t>
                       </a:r>
                       <a:endParaRPr lang="en-US" sz="1150" dirty="0">
                         <a:latin typeface="Arial" charset="0"/>
@@ -32886,7 +32886,7 @@
                 <a:ea typeface="Georgia" pitchFamily="34" charset="-122"/>
                 <a:cs typeface="Georgia" pitchFamily="34" charset="-120"/>
               </a:rPr>
-              <a:t>86%</a:t>
+              <a:t>87%</a:t>
             </a:r>
             <a:endParaRPr lang="en-US" sz="5400" dirty="0"/>
           </a:p>
@@ -32925,7 +32925,7 @@
                 <a:ea typeface="Arial" pitchFamily="34" charset="-122"/>
                 <a:cs typeface="Arial" pitchFamily="34" charset="-120"/>
               </a:rPr>
-              <a:t>12 of 14 modules complete</a:t>
+              <a:t>13 of 15 modules complete</a:t>
             </a:r>
             <a:endParaRPr lang="en-US" sz="1350" dirty="0"/>
           </a:p>
@@ -33803,7 +33803,7 @@
                 <a:ea typeface="Arial" pitchFamily="34" charset="-122"/>
                 <a:cs typeface="Arial" pitchFamily="34" charset="-120"/>
               </a:rPr>
-              <a:t>Google Places / Distance providers — live-key testing</a:t>
+              <a:t>OpenStreetMap places + OSRM road distances (live)</a:t>
             </a:r>
             <a:endParaRPr lang="en-US" sz="1150" dirty="0"/>
           </a:p>
@@ -33818,6 +33818,129 @@
         <p:spPr>
           <a:xfrm>
             <a:off x="6274156" y="5074920"/>
+            <a:ext cx="987552" cy="246888"/>
+          </a:xfrm>
+          <a:prstGeom prst="roundRect">
+            <a:avLst>
+              <a:gd name="adj" fmla="val 48148"/>
+            </a:avLst>
+          </a:prstGeom>
+          <a:solidFill>
+            <a:srgbClr val="1F2A33"/>
+          </a:solidFill>
+          <a:ln/>
+        </p:spPr>
+      </p:sp>
+      <p:sp>
+        <p:nvSpPr>
+          <p:cNvPr id="39" name="Text 36"/>
+          <p:cNvSpPr txBox="1"/>
+          <p:nvPr/>
+        </p:nvSpPr>
+        <p:spPr>
+          <a:xfrm>
+            <a:off x="6274156" y="5074920"/>
+            <a:ext cx="987552" cy="246888"/>
+          </a:xfrm>
+          <a:prstGeom prst="rect">
+            <a:avLst/>
+          </a:prstGeom>
+          <a:noFill/>
+          <a:ln/>
+        </p:spPr>
+        <p:txBody>
+          <a:bodyPr wrap="square" lIns="0" tIns="0" rIns="0" bIns="0" rtlCol="0" anchor="ctr"/>
+          <a:lstStyle/>
+          <a:p>
+            <a:pPr algn="ctr" indent="0" marL="0">
+              <a:buNone/>
+            </a:pPr>
+            <a:r>
+              <a:rPr lang="en-US" sz="850" b="1" spc="100" kern="0" dirty="0">
+                <a:solidFill>
+                  <a:srgbClr val="F6F1E7"/>
+                </a:solidFill>
+                <a:latin typeface="Arial" pitchFamily="34" charset="0"/>
+                <a:ea typeface="Arial" pitchFamily="34" charset="-122"/>
+                <a:cs typeface="Arial" pitchFamily="34" charset="-120"/>
+              </a:rPr>
+              <a:t>DONE</a:t>
+            </a:r>
+            <a:endParaRPr lang="en-US" sz="850" dirty="0"/>
+          </a:p>
+        </p:txBody>
+      </p:sp>
+      <p:sp>
+        <p:nvSpPr>
+          <p:cNvPr id="40" name="Shape 37"/>
+          <p:cNvSpPr/>
+          <p:nvPr/>
+        </p:nvSpPr>
+        <p:spPr>
+          <a:xfrm>
+            <a:off x="3383280" y="5870448"/>
+            <a:ext cx="3878428" cy="0"/>
+          </a:xfrm>
+          <a:prstGeom prst="line">
+            <a:avLst/>
+          </a:prstGeom>
+          <a:noFill/>
+          <a:ln w="9525">
+            <a:solidFill>
+              <a:srgbClr val="D8CDB9"/>
+            </a:solidFill>
+            <a:prstDash val="solid"/>
+          </a:ln>
+        </p:spPr>
+      </p:sp>
+      <p:sp>
+        <p:nvSpPr>
+          <p:cNvPr id="41" name="Text 38"/>
+          <p:cNvSpPr txBox="1"/>
+          <p:nvPr/>
+        </p:nvSpPr>
+        <p:spPr>
+          <a:xfrm>
+            <a:off x="3383280" y="5422392"/>
+            <a:ext cx="2781148" cy="448056"/>
+          </a:xfrm>
+          <a:prstGeom prst="rect">
+            <a:avLst/>
+          </a:prstGeom>
+          <a:noFill/>
+          <a:ln/>
+        </p:spPr>
+        <p:txBody>
+          <a:bodyPr wrap="square" lIns="0" tIns="0" rIns="0" bIns="0" rtlCol="0" anchor="ctr"/>
+          <a:lstStyle/>
+          <a:p>
+            <a:pPr indent="0" marL="0">
+              <a:buNone/>
+            </a:pPr>
+            <a:r>
+              <a:rPr lang="en-US" sz="1150" dirty="0">
+                <a:solidFill>
+                  <a:srgbClr val="1F2A33"/>
+                </a:solidFill>
+                <a:latin typeface="Arial" pitchFamily="34" charset="0"/>
+                <a:ea typeface="Arial" pitchFamily="34" charset="-122"/>
+                <a:cs typeface="Arial" pitchFamily="34" charset="-120"/>
+              </a:rPr>
+              <a:t>Google Places / Distance providers — live-key testing</a:t>
+            </a:r>
+            <a:endParaRPr lang="en-US" sz="1150" dirty="0"/>
+          </a:p>
+        </p:txBody>
+      </p:sp>
+      <p:sp>
+        <p:nvSpPr>
+          <p:cNvPr id="42" name="Shape 39"/>
+          <p:cNvSpPr/>
+          <p:nvPr/>
+        </p:nvSpPr>
+        <p:spPr>
+          <a:xfrm>
+            <a:off x="6274156" y="5522976"/>
             <a:ext cx="987552" cy="246888"/>
           </a:xfrm>
           <a:prstGeom prst="roundRect">
@@ -33838,13 +33961,13 @@
       </p:sp>
       <p:sp>
         <p:nvSpPr>
-          <p:cNvPr id="39" name="Text 36"/>
+          <p:cNvPr id="43" name="Text 40"/>
           <p:cNvSpPr txBox="1"/>
           <p:nvPr/>
         </p:nvSpPr>
         <p:spPr>
           <a:xfrm>
-            <a:off x="6274156" y="5074920"/>
+            <a:off x="6274156" y="5522976"/>
             <a:ext cx="987552" cy="246888"/>
           </a:xfrm>
           <a:prstGeom prst="rect">
@@ -33877,13 +34000,13 @@
       </p:sp>
       <p:sp>
         <p:nvSpPr>
-          <p:cNvPr id="40" name="Shape 37"/>
+          <p:cNvPr id="44" name="Shape 41"/>
           <p:cNvSpPr/>
           <p:nvPr/>
         </p:nvSpPr>
         <p:spPr>
           <a:xfrm>
-            <a:off x="3383280" y="5870448"/>
+            <a:off x="3383280" y="6318504"/>
             <a:ext cx="3878428" cy="0"/>
           </a:xfrm>
           <a:prstGeom prst="line">
@@ -33900,13 +34023,13 @@
       </p:sp>
       <p:sp>
         <p:nvSpPr>
-          <p:cNvPr id="41" name="Text 38"/>
+          <p:cNvPr id="45" name="Text 42"/>
           <p:cNvSpPr txBox="1"/>
           <p:nvPr/>
         </p:nvSpPr>
         <p:spPr>
           <a:xfrm>
-            <a:off x="3383280" y="5422392"/>
+            <a:off x="3383280" y="5870448"/>
             <a:ext cx="2781148" cy="448056"/>
           </a:xfrm>
           <a:prstGeom prst="rect">
@@ -33939,13 +34062,13 @@
       </p:sp>
       <p:sp>
         <p:nvSpPr>
-          <p:cNvPr id="42" name="Shape 39"/>
+          <p:cNvPr id="46" name="Shape 43"/>
           <p:cNvSpPr/>
           <p:nvPr/>
         </p:nvSpPr>
         <p:spPr>
           <a:xfrm>
-            <a:off x="6274156" y="5522976"/>
+            <a:off x="6274156" y="5971032"/>
             <a:ext cx="987552" cy="246888"/>
           </a:xfrm>
           <a:prstGeom prst="roundRect">
@@ -33961,13 +34084,13 @@
       </p:sp>
       <p:sp>
         <p:nvSpPr>
-          <p:cNvPr id="43" name="Text 40"/>
+          <p:cNvPr id="47" name="Text 44"/>
           <p:cNvSpPr txBox="1"/>
           <p:nvPr/>
         </p:nvSpPr>
         <p:spPr>
           <a:xfrm>
-            <a:off x="6274156" y="5522976"/>
+            <a:off x="6274156" y="5971032"/>
             <a:ext cx="987552" cy="246888"/>
           </a:xfrm>
           <a:prstGeom prst="rect">
@@ -34000,7 +34123,7 @@
       </p:sp>
       <p:sp>
         <p:nvSpPr>
-          <p:cNvPr id="44" name="Text 41"/>
+          <p:cNvPr id="48" name="Text 45"/>
           <p:cNvSpPr txBox="1"/>
           <p:nvPr/>
         </p:nvSpPr>
@@ -34039,7 +34162,7 @@
       </p:sp>
       <p:sp>
         <p:nvSpPr>
-          <p:cNvPr id="45" name="Shape 42"/>
+          <p:cNvPr id="49" name="Shape 46"/>
           <p:cNvSpPr/>
           <p:nvPr/>
         </p:nvSpPr>
@@ -34062,7 +34185,7 @@
       </p:sp>
       <p:sp>
         <p:nvSpPr>
-          <p:cNvPr id="46" name="Text 43"/>
+          <p:cNvPr id="50" name="Text 47"/>
           <p:cNvSpPr txBox="1"/>
           <p:nvPr/>
         </p:nvSpPr>
@@ -34101,7 +34224,7 @@
       </p:sp>
       <p:sp>
         <p:nvSpPr>
-          <p:cNvPr id="47" name="Shape 44"/>
+          <p:cNvPr id="51" name="Shape 48"/>
           <p:cNvSpPr/>
           <p:nvPr/>
         </p:nvSpPr>
@@ -34123,7 +34246,7 @@
       </p:sp>
       <p:sp>
         <p:nvSpPr>
-          <p:cNvPr id="48" name="Text 45"/>
+          <p:cNvPr id="52" name="Text 49"/>
           <p:cNvSpPr txBox="1"/>
           <p:nvPr/>
         </p:nvSpPr>
@@ -34162,7 +34285,7 @@
       </p:sp>
       <p:sp>
         <p:nvSpPr>
-          <p:cNvPr id="49" name="Shape 46"/>
+          <p:cNvPr id="53" name="Shape 50"/>
           <p:cNvSpPr/>
           <p:nvPr/>
         </p:nvSpPr>
@@ -34185,7 +34308,7 @@
       </p:sp>
       <p:sp>
         <p:nvSpPr>
-          <p:cNvPr id="50" name="Text 47"/>
+          <p:cNvPr id="54" name="Text 51"/>
           <p:cNvSpPr txBox="1"/>
           <p:nvPr/>
         </p:nvSpPr>
@@ -34224,7 +34347,7 @@
       </p:sp>
       <p:sp>
         <p:nvSpPr>
-          <p:cNvPr id="51" name="Shape 48"/>
+          <p:cNvPr id="55" name="Shape 52"/>
           <p:cNvSpPr/>
           <p:nvPr/>
         </p:nvSpPr>
@@ -34246,7 +34369,7 @@
       </p:sp>
       <p:sp>
         <p:nvSpPr>
-          <p:cNvPr id="52" name="Text 49"/>
+          <p:cNvPr id="56" name="Text 53"/>
           <p:cNvSpPr txBox="1"/>
           <p:nvPr/>
         </p:nvSpPr>
@@ -34285,7 +34408,7 @@
       </p:sp>
       <p:sp>
         <p:nvSpPr>
-          <p:cNvPr id="53" name="Shape 50"/>
+          <p:cNvPr id="57" name="Shape 54"/>
           <p:cNvSpPr/>
           <p:nvPr/>
         </p:nvSpPr>
@@ -34308,7 +34431,7 @@
       </p:sp>
       <p:sp>
         <p:nvSpPr>
-          <p:cNvPr id="54" name="Text 51"/>
+          <p:cNvPr id="58" name="Text 55"/>
           <p:cNvSpPr txBox="1"/>
           <p:nvPr/>
         </p:nvSpPr>
@@ -34347,7 +34470,7 @@
       </p:sp>
       <p:sp>
         <p:nvSpPr>
-          <p:cNvPr id="55" name="Shape 52"/>
+          <p:cNvPr id="59" name="Shape 56"/>
           <p:cNvSpPr/>
           <p:nvPr/>
         </p:nvSpPr>
@@ -34369,7 +34492,7 @@
       </p:sp>
       <p:sp>
         <p:nvSpPr>
-          <p:cNvPr id="56" name="Text 53"/>
+          <p:cNvPr id="60" name="Text 57"/>
           <p:cNvSpPr txBox="1"/>
           <p:nvPr/>
         </p:nvSpPr>
@@ -34408,7 +34531,7 @@
       </p:sp>
       <p:sp>
         <p:nvSpPr>
-          <p:cNvPr id="57" name="Shape 54"/>
+          <p:cNvPr id="61" name="Shape 58"/>
           <p:cNvSpPr/>
           <p:nvPr/>
         </p:nvSpPr>
@@ -34431,7 +34554,7 @@
       </p:sp>
       <p:sp>
         <p:nvSpPr>
-          <p:cNvPr id="58" name="Text 55"/>
+          <p:cNvPr id="62" name="Text 59"/>
           <p:cNvSpPr txBox="1"/>
           <p:nvPr/>
         </p:nvSpPr>
@@ -34470,7 +34593,7 @@
       </p:sp>
       <p:sp>
         <p:nvSpPr>
-          <p:cNvPr id="59" name="Shape 56"/>
+          <p:cNvPr id="63" name="Shape 60"/>
           <p:cNvSpPr/>
           <p:nvPr/>
         </p:nvSpPr>
@@ -34492,7 +34615,7 @@
       </p:sp>
       <p:sp>
         <p:nvSpPr>
-          <p:cNvPr id="60" name="Text 57"/>
+          <p:cNvPr id="64" name="Text 61"/>
           <p:cNvSpPr txBox="1"/>
           <p:nvPr/>
         </p:nvSpPr>
@@ -34531,7 +34654,7 @@
       </p:sp>
       <p:sp>
         <p:nvSpPr>
-          <p:cNvPr id="61" name="Shape 58"/>
+          <p:cNvPr id="65" name="Shape 62"/>
           <p:cNvSpPr/>
           <p:nvPr/>
         </p:nvSpPr>
@@ -34554,7 +34677,7 @@
       </p:sp>
       <p:sp>
         <p:nvSpPr>
-          <p:cNvPr id="62" name="Text 59"/>
+          <p:cNvPr id="66" name="Text 63"/>
           <p:cNvSpPr txBox="1"/>
           <p:nvPr/>
         </p:nvSpPr>
@@ -34593,7 +34716,7 @@
       </p:sp>
       <p:sp>
         <p:nvSpPr>
-          <p:cNvPr id="63" name="Shape 60"/>
+          <p:cNvPr id="67" name="Shape 64"/>
           <p:cNvSpPr/>
           <p:nvPr/>
         </p:nvSpPr>
@@ -34615,7 +34738,7 @@
       </p:sp>
       <p:sp>
         <p:nvSpPr>
-          <p:cNvPr id="64" name="Text 61"/>
+          <p:cNvPr id="68" name="Text 65"/>
           <p:cNvSpPr txBox="1"/>
           <p:nvPr/>
         </p:nvSpPr>
@@ -34654,7 +34777,7 @@
       </p:sp>
       <p:sp>
         <p:nvSpPr>
-          <p:cNvPr id="65" name="Shape 62"/>
+          <p:cNvPr id="69" name="Shape 66"/>
           <p:cNvSpPr/>
           <p:nvPr/>
         </p:nvSpPr>
@@ -34677,7 +34800,7 @@
       </p:sp>
       <p:sp>
         <p:nvSpPr>
-          <p:cNvPr id="66" name="Text 63"/>
+          <p:cNvPr id="70" name="Text 67"/>
           <p:cNvSpPr txBox="1"/>
           <p:nvPr/>
         </p:nvSpPr>
@@ -34716,7 +34839,7 @@
       </p:sp>
       <p:sp>
         <p:nvSpPr>
-          <p:cNvPr id="67" name="Shape 64"/>
+          <p:cNvPr id="71" name="Shape 68"/>
           <p:cNvSpPr/>
           <p:nvPr/>
         </p:nvSpPr>
@@ -34743,7 +34866,7 @@
       </p:sp>
       <p:sp>
         <p:nvSpPr>
-          <p:cNvPr id="68" name="Text 65"/>
+          <p:cNvPr id="72" name="Text 69"/>
           <p:cNvSpPr txBox="1"/>
           <p:nvPr/>
         </p:nvSpPr>
@@ -39427,7 +39550,7 @@
                 <a:ea typeface="Arial" pitchFamily="34" charset="-122"/>
                 <a:cs typeface="Arial" pitchFamily="34" charset="-120"/>
               </a:rPr>
-              <a:t>Seeded data and a local distance provider by default; Google APIs are optional.</a:t>
+              <a:t>Seeded data and a local distance provider by default; OpenStreetMap and Google are optional.</a:t>
             </a:r>
             <a:endParaRPr lang="en-US" sz="1350" dirty="0"/>
           </a:p>
@@ -42793,7 +42916,7 @@
                 <a:ea typeface="Arial" pitchFamily="34" charset="-122"/>
                 <a:cs typeface="Arial" pitchFamily="34" charset="-120"/>
               </a:rPr>
-              <a:t>Route and Places adapters: local default, Google optional.</a:t>
+              <a:t>Route and Places adapters: local, OpenStreetMap (free) or Google.</a:t>
             </a:r>
             <a:endParaRPr lang="en-US" sz="1250" dirty="0"/>
           </a:p>
@@ -43030,8 +43153,8 @@
         </p:blipFill>
         <p:spPr>
           <a:xfrm>
-            <a:off x="2238703" y="1453896"/>
-            <a:ext cx="7714290" cy="4206240"/>
+            <a:off x="2128149" y="1453896"/>
+            <a:ext cx="7935396" cy="4206240"/>
           </a:xfrm>
           <a:prstGeom prst="rect">
             <a:avLst/>
@@ -43071,7 +43194,7 @@
                 <a:ea typeface="Arial" pitchFamily="34" charset="-122"/>
                 <a:cs typeface="Arial" pitchFamily="34" charset="-120"/>
               </a:rPr>
-              <a:t>Browser → REST API → MongoDB. Google services are optional; every call falls back to the local provider.</a:t>
+              <a:t>Browser → REST API → MongoDB. External map services are optional; every call falls back to the local provider.</a:t>
             </a:r>
             <a:endParaRPr lang="en-US" sz="1250" dirty="0"/>
           </a:p>

</xml_diff>

<commit_message>
docs: project document and deck in the college format
Title page per the department's Annexure-2 with the SVIT emblem,
acknowledgement, abstract and INDEX table, roman front-matter numbering,
Times New Roman 16/14/12/10, enrollment numbers in the footer. Team and
guide details filled in; emblem added to the deck's title slide.

Co-Authored-By: Claude Fable 5.1 <noreply@anthropic.com>
</commit_message>
<xml_diff>
--- a/docs/Smart_Trip_Planner_Presentation1.pptx
+++ b/docs/Smart_Trip_Planner_Presentation1.pptx
@@ -3492,6 +3492,52 @@
         </p:nvSpPr>
         <p:spPr>
           <a:xfrm>
+            <a:off x="10134295" y="502920"/>
+            <a:ext cx="1371600" cy="1371600"/>
+          </a:xfrm>
+          <a:prstGeom prst="roundRect">
+            <a:avLst>
+              <a:gd name="adj" fmla="val 4000"/>
+            </a:avLst>
+          </a:prstGeom>
+          <a:solidFill>
+            <a:srgbClr val="FFFFFF"/>
+          </a:solidFill>
+          <a:ln/>
+        </p:spPr>
+      </p:sp>
+      <p:pic>
+        <p:nvPicPr>
+          <p:cNvPr id="7" name="Image 0" descr="SVIT logo">    </p:cNvPr>
+          <p:cNvPicPr>
+            <a:picLocks noChangeAspect="1"/>
+          </p:cNvPicPr>
+          <p:nvPr/>
+        </p:nvPicPr>
+        <p:blipFill>
+          <a:blip r:embed="rId1"/>
+          <a:stretch>
+            <a:fillRect/>
+          </a:stretch>
+        </p:blipFill>
+        <p:spPr>
+          <a:xfrm>
+            <a:off x="10244023" y="612648"/>
+            <a:ext cx="1152144" cy="1122976"/>
+          </a:xfrm>
+          <a:prstGeom prst="rect">
+            <a:avLst/>
+          </a:prstGeom>
+        </p:spPr>
+      </p:pic>
+      <p:sp>
+        <p:nvSpPr>
+          <p:cNvPr id="8" name="Shape 4"/>
+          <p:cNvSpPr/>
+          <p:nvPr/>
+        </p:nvSpPr>
+        <p:spPr>
+          <a:xfrm>
             <a:off x="896112" y="3520440"/>
             <a:ext cx="6995160" cy="0"/>
           </a:xfrm>
@@ -3509,7 +3555,7 @@
       </p:sp>
       <p:sp>
         <p:nvSpPr>
-          <p:cNvPr id="7" name="Shape 4"/>
+          <p:cNvPr id="9" name="Shape 5"/>
           <p:cNvSpPr/>
           <p:nvPr/>
         </p:nvSpPr>
@@ -3529,7 +3575,7 @@
       </p:sp>
       <p:sp>
         <p:nvSpPr>
-          <p:cNvPr id="8" name="Text 5"/>
+          <p:cNvPr id="10" name="Text 6"/>
           <p:cNvSpPr txBox="1"/>
           <p:nvPr/>
         </p:nvSpPr>
@@ -3568,7 +3614,7 @@
       </p:sp>
       <p:sp>
         <p:nvSpPr>
-          <p:cNvPr id="9" name="Text 6"/>
+          <p:cNvPr id="11" name="Text 7"/>
           <p:cNvSpPr txBox="1"/>
           <p:nvPr/>
         </p:nvSpPr>
@@ -3607,7 +3653,7 @@
       </p:sp>
       <p:sp>
         <p:nvSpPr>
-          <p:cNvPr id="10" name="Shape 7"/>
+          <p:cNvPr id="12" name="Shape 8"/>
           <p:cNvSpPr/>
           <p:nvPr/>
         </p:nvSpPr>
@@ -3627,7 +3673,7 @@
       </p:sp>
       <p:sp>
         <p:nvSpPr>
-          <p:cNvPr id="11" name="Text 8"/>
+          <p:cNvPr id="13" name="Text 9"/>
           <p:cNvSpPr txBox="1"/>
           <p:nvPr/>
         </p:nvSpPr>
@@ -3666,7 +3712,7 @@
       </p:sp>
       <p:sp>
         <p:nvSpPr>
-          <p:cNvPr id="12" name="Text 9"/>
+          <p:cNvPr id="14" name="Text 10"/>
           <p:cNvSpPr txBox="1"/>
           <p:nvPr/>
         </p:nvSpPr>
@@ -3705,7 +3751,7 @@
       </p:sp>
       <p:sp>
         <p:nvSpPr>
-          <p:cNvPr id="13" name="Shape 10"/>
+          <p:cNvPr id="15" name="Shape 11"/>
           <p:cNvSpPr/>
           <p:nvPr/>
         </p:nvSpPr>
@@ -3725,7 +3771,7 @@
       </p:sp>
       <p:sp>
         <p:nvSpPr>
-          <p:cNvPr id="14" name="Text 11"/>
+          <p:cNvPr id="16" name="Text 12"/>
           <p:cNvSpPr txBox="1"/>
           <p:nvPr/>
         </p:nvSpPr>
@@ -3764,7 +3810,7 @@
       </p:sp>
       <p:sp>
         <p:nvSpPr>
-          <p:cNvPr id="15" name="Text 12"/>
+          <p:cNvPr id="17" name="Text 13"/>
           <p:cNvSpPr txBox="1"/>
           <p:nvPr/>
         </p:nvSpPr>
@@ -3803,7 +3849,7 @@
       </p:sp>
       <p:sp>
         <p:nvSpPr>
-          <p:cNvPr id="16" name="Shape 13"/>
+          <p:cNvPr id="18" name="Shape 14"/>
           <p:cNvSpPr/>
           <p:nvPr/>
         </p:nvSpPr>
@@ -3823,7 +3869,7 @@
       </p:sp>
       <p:sp>
         <p:nvSpPr>
-          <p:cNvPr id="17" name="Text 14"/>
+          <p:cNvPr id="19" name="Text 15"/>
           <p:cNvSpPr txBox="1"/>
           <p:nvPr/>
         </p:nvSpPr>
@@ -3862,7 +3908,7 @@
       </p:sp>
       <p:sp>
         <p:nvSpPr>
-          <p:cNvPr id="18" name="Text 15"/>
+          <p:cNvPr id="20" name="Text 16"/>
           <p:cNvSpPr txBox="1"/>
           <p:nvPr/>
         </p:nvSpPr>
@@ -3901,7 +3947,7 @@
       </p:sp>
       <p:sp>
         <p:nvSpPr>
-          <p:cNvPr id="19" name="Text 16"/>
+          <p:cNvPr id="21" name="Text 17"/>
           <p:cNvSpPr txBox="1"/>
           <p:nvPr/>
         </p:nvSpPr>
@@ -3940,7 +3986,7 @@
       </p:sp>
       <p:sp>
         <p:nvSpPr>
-          <p:cNvPr id="20" name="Text 17"/>
+          <p:cNvPr id="22" name="Text 18"/>
           <p:cNvSpPr txBox="1"/>
           <p:nvPr/>
         </p:nvSpPr>
@@ -3979,7 +4025,7 @@
       </p:sp>
       <p:sp>
         <p:nvSpPr>
-          <p:cNvPr id="21" name="Text 18"/>
+          <p:cNvPr id="23" name="Text 19"/>
           <p:cNvSpPr txBox="1"/>
           <p:nvPr/>
         </p:nvSpPr>
@@ -4002,18 +4048,15 @@
               <a:buNone/>
             </a:pPr>
             <a:r>
-              <a:rPr lang="en-US" sz="1300" b="1" dirty="0">
-                <a:solidFill>
-                  <a:srgbClr val="1F2A33"/>
-                </a:solidFill>
-                <a:highlight>
-                  <a:srgbClr val="FFE066"/>
-                </a:highlight>
+              <a:rPr lang="en-US" sz="1300" dirty="0">
+                <a:solidFill>
+                  <a:srgbClr val="F6F1E7"/>
+                </a:solidFill>
                 <a:latin typeface="Arial" pitchFamily="34" charset="0"/>
                 <a:ea typeface="Arial" pitchFamily="34" charset="-122"/>
                 <a:cs typeface="Arial" pitchFamily="34" charset="-120"/>
               </a:rPr>
-              <a:t>[[ENROLLMENT NO]]</a:t>
+              <a:t>255300694026</a:t>
             </a:r>
             <a:endParaRPr lang="en-US" sz="1400" dirty="0"/>
           </a:p>
@@ -4021,7 +4064,7 @@
       </p:sp>
       <p:sp>
         <p:nvSpPr>
-          <p:cNvPr id="22" name="Text 19"/>
+          <p:cNvPr id="24" name="Text 20"/>
           <p:cNvSpPr txBox="1"/>
           <p:nvPr/>
         </p:nvSpPr>
@@ -4060,7 +4103,7 @@
       </p:sp>
       <p:sp>
         <p:nvSpPr>
-          <p:cNvPr id="23" name="Text 20"/>
+          <p:cNvPr id="25" name="Text 21"/>
           <p:cNvSpPr txBox="1"/>
           <p:nvPr/>
         </p:nvSpPr>
@@ -4099,7 +4142,7 @@
       </p:sp>
       <p:sp>
         <p:nvSpPr>
-          <p:cNvPr id="24" name="Text 21"/>
+          <p:cNvPr id="26" name="Text 22"/>
           <p:cNvSpPr txBox="1"/>
           <p:nvPr/>
         </p:nvSpPr>
@@ -4122,18 +4165,15 @@
               <a:buNone/>
             </a:pPr>
             <a:r>
-              <a:rPr lang="en-US" sz="1300" b="1" dirty="0">
-                <a:solidFill>
-                  <a:srgbClr val="1F2A33"/>
-                </a:solidFill>
-                <a:highlight>
-                  <a:srgbClr val="FFE066"/>
-                </a:highlight>
+              <a:rPr lang="en-US" sz="1300" dirty="0">
+                <a:solidFill>
+                  <a:srgbClr val="F6F1E7"/>
+                </a:solidFill>
                 <a:latin typeface="Arial" pitchFamily="34" charset="0"/>
                 <a:ea typeface="Arial" pitchFamily="34" charset="-122"/>
                 <a:cs typeface="Arial" pitchFamily="34" charset="-120"/>
               </a:rPr>
-              <a:t>[[ENROLLMENT NO]]</a:t>
+              <a:t>255300694009</a:t>
             </a:r>
             <a:endParaRPr lang="en-US" sz="1400" dirty="0"/>
           </a:p>
@@ -4141,7 +4181,7 @@
       </p:sp>
       <p:sp>
         <p:nvSpPr>
-          <p:cNvPr id="25" name="Text 22"/>
+          <p:cNvPr id="27" name="Text 23"/>
           <p:cNvSpPr txBox="1"/>
           <p:nvPr/>
         </p:nvSpPr>
@@ -4180,7 +4220,7 @@
       </p:sp>
       <p:sp>
         <p:nvSpPr>
-          <p:cNvPr id="26" name="Text 23"/>
+          <p:cNvPr id="28" name="Text 24"/>
           <p:cNvSpPr txBox="1"/>
           <p:nvPr/>
         </p:nvSpPr>
@@ -4211,24 +4251,7 @@
                 <a:ea typeface="Georgia" pitchFamily="34" charset="-122"/>
                 <a:cs typeface="Georgia" pitchFamily="34" charset="-120"/>
               </a:rPr>
-              <a:t>Vraj </a:t>
-            </a:r>
-            <a:pPr indent="0" marL="0">
-              <a:buNone/>
-            </a:pPr>
-            <a:r>
-              <a:rPr lang="en-US" sz="1600" b="1" dirty="0">
-                <a:solidFill>
-                  <a:srgbClr val="1F2A33"/>
-                </a:solidFill>
-                <a:highlight>
-                  <a:srgbClr val="FFE066"/>
-                </a:highlight>
-                <a:latin typeface="Georgia" pitchFamily="34" charset="0"/>
-                <a:ea typeface="Georgia" pitchFamily="34" charset="-122"/>
-                <a:cs typeface="Georgia" pitchFamily="34" charset="-120"/>
-              </a:rPr>
-              <a:t>[[SURNAME]]</a:t>
+              <a:t>Vraj Panchal</a:t>
             </a:r>
             <a:endParaRPr lang="en-US" sz="1400" dirty="0"/>
           </a:p>
@@ -4236,7 +4259,7 @@
       </p:sp>
       <p:sp>
         <p:nvSpPr>
-          <p:cNvPr id="27" name="Text 24"/>
+          <p:cNvPr id="29" name="Text 25"/>
           <p:cNvSpPr txBox="1"/>
           <p:nvPr/>
         </p:nvSpPr>
@@ -4259,18 +4282,15 @@
               <a:buNone/>
             </a:pPr>
             <a:r>
-              <a:rPr lang="en-US" sz="1300" b="1" dirty="0">
-                <a:solidFill>
-                  <a:srgbClr val="1F2A33"/>
-                </a:solidFill>
-                <a:highlight>
-                  <a:srgbClr val="FFE066"/>
-                </a:highlight>
+              <a:rPr lang="en-US" sz="1300" dirty="0">
+                <a:solidFill>
+                  <a:srgbClr val="F6F1E7"/>
+                </a:solidFill>
                 <a:latin typeface="Arial" pitchFamily="34" charset="0"/>
                 <a:ea typeface="Arial" pitchFamily="34" charset="-122"/>
                 <a:cs typeface="Arial" pitchFamily="34" charset="-120"/>
               </a:rPr>
-              <a:t>[[ENROLLMENT NO]]</a:t>
+              <a:t>255300694064</a:t>
             </a:r>
             <a:endParaRPr lang="en-US" sz="1400" dirty="0"/>
           </a:p>
@@ -4278,7 +4298,7 @@
       </p:sp>
       <p:sp>
         <p:nvSpPr>
-          <p:cNvPr id="28" name="Text 25"/>
+          <p:cNvPr id="30" name="Text 26"/>
           <p:cNvSpPr txBox="1"/>
           <p:nvPr/>
         </p:nvSpPr>
@@ -4317,7 +4337,7 @@
       </p:sp>
       <p:sp>
         <p:nvSpPr>
-          <p:cNvPr id="29" name="Text 26"/>
+          <p:cNvPr id="31" name="Text 27"/>
           <p:cNvSpPr txBox="1"/>
           <p:nvPr/>
         </p:nvSpPr>
@@ -4356,7 +4376,7 @@
       </p:sp>
       <p:sp>
         <p:nvSpPr>
-          <p:cNvPr id="30" name="Text 27"/>
+          <p:cNvPr id="32" name="Text 28"/>
           <p:cNvSpPr txBox="1"/>
           <p:nvPr/>
         </p:nvSpPr>
@@ -4379,18 +4399,15 @@
               <a:buNone/>
             </a:pPr>
             <a:r>
-              <a:rPr lang="en-US" sz="1400" b="1" dirty="0">
-                <a:solidFill>
-                  <a:srgbClr val="1F2A33"/>
-                </a:solidFill>
-                <a:highlight>
-                  <a:srgbClr val="FFE066"/>
-                </a:highlight>
+              <a:rPr lang="en-US" sz="1400" dirty="0">
+                <a:solidFill>
+                  <a:srgbClr val="F6F1E7"/>
+                </a:solidFill>
                 <a:latin typeface="Arial" pitchFamily="34" charset="0"/>
                 <a:ea typeface="Arial" pitchFamily="34" charset="-122"/>
                 <a:cs typeface="Arial" pitchFamily="34" charset="-120"/>
               </a:rPr>
-              <a:t>[[GUIDE NAME]]</a:t>
+              <a:t>Prof. Payal Chauhan</a:t>
             </a:r>
             <a:endParaRPr lang="en-US" sz="1400" dirty="0"/>
           </a:p>
@@ -4398,13 +4415,13 @@
       </p:sp>
       <p:sp>
         <p:nvSpPr>
-          <p:cNvPr id="31" name="Text 28"/>
+          <p:cNvPr id="33" name="Text 29"/>
           <p:cNvSpPr txBox="1"/>
           <p:nvPr/>
         </p:nvSpPr>
         <p:spPr>
           <a:xfrm>
-            <a:off x="8549640" y="4946904"/>
+            <a:off x="8549640" y="5093208"/>
             <a:ext cx="2956255" cy="201168"/>
           </a:xfrm>
           <a:prstGeom prst="rect">
@@ -4429,7 +4446,7 @@
                 <a:ea typeface="Arial" pitchFamily="34" charset="-122"/>
                 <a:cs typeface="Arial" pitchFamily="34" charset="-120"/>
               </a:rPr>
-              <a:t>TEAM</a:t>
+              <a:t>PRESENTATION-1</a:t>
             </a:r>
             <a:endParaRPr lang="en-US" sz="1000" dirty="0"/>
           </a:p>
@@ -4437,13 +4454,13 @@
       </p:sp>
       <p:sp>
         <p:nvSpPr>
-          <p:cNvPr id="32" name="Text 29"/>
+          <p:cNvPr id="34" name="Text 30"/>
           <p:cNvSpPr txBox="1"/>
           <p:nvPr/>
         </p:nvSpPr>
         <p:spPr>
           <a:xfrm>
-            <a:off x="8549640" y="5157216"/>
+            <a:off x="8549640" y="5303520"/>
             <a:ext cx="2956255" cy="274320"/>
           </a:xfrm>
           <a:prstGeom prst="rect">
@@ -4460,18 +4477,15 @@
               <a:buNone/>
             </a:pPr>
             <a:r>
-              <a:rPr lang="en-US" sz="1400" b="1" dirty="0">
-                <a:solidFill>
-                  <a:srgbClr val="1F2A33"/>
-                </a:solidFill>
-                <a:highlight>
-                  <a:srgbClr val="FFE066"/>
-                </a:highlight>
+              <a:rPr lang="en-US" sz="1400" dirty="0">
+                <a:solidFill>
+                  <a:srgbClr val="F6F1E7"/>
+                </a:solidFill>
                 <a:latin typeface="Arial" pitchFamily="34" charset="0"/>
                 <a:ea typeface="Arial" pitchFamily="34" charset="-122"/>
                 <a:cs typeface="Arial" pitchFamily="34" charset="-120"/>
               </a:rPr>
-              <a:t>[[TEAM NO]]</a:t>
+              <a:t>21 September 2026</a:t>
             </a:r>
             <a:endParaRPr lang="en-US" sz="1400" dirty="0"/>
           </a:p>
@@ -4479,85 +4493,7 @@
       </p:sp>
       <p:sp>
         <p:nvSpPr>
-          <p:cNvPr id="33" name="Text 30"/>
-          <p:cNvSpPr txBox="1"/>
-          <p:nvPr/>
-        </p:nvSpPr>
-        <p:spPr>
-          <a:xfrm>
-            <a:off x="8549640" y="5458968"/>
-            <a:ext cx="2956255" cy="201168"/>
-          </a:xfrm>
-          <a:prstGeom prst="rect">
-            <a:avLst/>
-          </a:prstGeom>
-          <a:noFill/>
-          <a:ln/>
-        </p:spPr>
-        <p:txBody>
-          <a:bodyPr wrap="square" lIns="0" tIns="0" rIns="0" bIns="0" rtlCol="0" anchor="t"/>
-          <a:lstStyle/>
-          <a:p>
-            <a:pPr indent="0" marL="0">
-              <a:buNone/>
-            </a:pPr>
-            <a:r>
-              <a:rPr lang="en-US" sz="1000" b="1" spc="300" kern="0" dirty="0">
-                <a:solidFill>
-                  <a:srgbClr val="AEB6BC"/>
-                </a:solidFill>
-                <a:latin typeface="Arial" pitchFamily="34" charset="0"/>
-                <a:ea typeface="Arial" pitchFamily="34" charset="-122"/>
-                <a:cs typeface="Arial" pitchFamily="34" charset="-120"/>
-              </a:rPr>
-              <a:t>PRESENTATION-1</a:t>
-            </a:r>
-            <a:endParaRPr lang="en-US" sz="1000" dirty="0"/>
-          </a:p>
-        </p:txBody>
-      </p:sp>
-      <p:sp>
-        <p:nvSpPr>
-          <p:cNvPr id="34" name="Text 31"/>
-          <p:cNvSpPr txBox="1"/>
-          <p:nvPr/>
-        </p:nvSpPr>
-        <p:spPr>
-          <a:xfrm>
-            <a:off x="8549640" y="5669280"/>
-            <a:ext cx="2956255" cy="274320"/>
-          </a:xfrm>
-          <a:prstGeom prst="rect">
-            <a:avLst/>
-          </a:prstGeom>
-          <a:noFill/>
-          <a:ln/>
-        </p:spPr>
-        <p:txBody>
-          <a:bodyPr wrap="square" lIns="0" tIns="0" rIns="0" bIns="0" rtlCol="0" anchor="t"/>
-          <a:lstStyle/>
-          <a:p>
-            <a:pPr indent="0" marL="0">
-              <a:buNone/>
-            </a:pPr>
-            <a:r>
-              <a:rPr lang="en-US" sz="1400" dirty="0">
-                <a:solidFill>
-                  <a:srgbClr val="F6F1E7"/>
-                </a:solidFill>
-                <a:latin typeface="Arial" pitchFamily="34" charset="0"/>
-                <a:ea typeface="Arial" pitchFamily="34" charset="-122"/>
-                <a:cs typeface="Arial" pitchFamily="34" charset="-120"/>
-              </a:rPr>
-              <a:t>21 September 2026</a:t>
-            </a:r>
-            <a:endParaRPr lang="en-US" sz="1400" dirty="0"/>
-          </a:p>
-        </p:txBody>
-      </p:sp>
-      <p:sp>
-        <p:nvSpPr>
-          <p:cNvPr id="35" name="Text 32"/>
+          <p:cNvPr id="35" name="Text 31"/>
           <p:cNvSpPr txBox="1"/>
           <p:nvPr/>
         </p:nvSpPr>
@@ -8050,11 +7986,11 @@
         <p:spPr>
           <a:xfrm>
             <a:off x="6263640" y="2331720"/>
-            <a:ext cx="2506828" cy="1051560"/>
+            <a:ext cx="2529688" cy="1143000"/>
           </a:xfrm>
           <a:prstGeom prst="roundRect">
             <a:avLst>
-              <a:gd name="adj" fmla="val 5217"/>
+              <a:gd name="adj" fmla="val 4800"/>
             </a:avLst>
           </a:prstGeom>
           <a:solidFill>
@@ -8076,8 +8012,8 @@
         </p:nvSpPr>
         <p:spPr>
           <a:xfrm>
-            <a:off x="6464808" y="2441448"/>
-            <a:ext cx="2104492" cy="502920"/>
+            <a:off x="6464808" y="2404872"/>
+            <a:ext cx="2127352" cy="502920"/>
           </a:xfrm>
           <a:prstGeom prst="rect">
             <a:avLst/>
@@ -8115,8 +8051,8 @@
         </p:nvSpPr>
         <p:spPr>
           <a:xfrm>
-            <a:off x="6464808" y="2971800"/>
-            <a:ext cx="2104492" cy="365760"/>
+            <a:off x="6464808" y="2916936"/>
+            <a:ext cx="2127352" cy="457200"/>
           </a:xfrm>
           <a:prstGeom prst="rect">
             <a:avLst/>
@@ -8154,12 +8090,12 @@
         </p:nvSpPr>
         <p:spPr>
           <a:xfrm>
-            <a:off x="8999068" y="2331720"/>
-            <a:ext cx="2506828" cy="1051560"/>
+            <a:off x="8976208" y="2331720"/>
+            <a:ext cx="2529688" cy="1143000"/>
           </a:xfrm>
           <a:prstGeom prst="roundRect">
             <a:avLst>
-              <a:gd name="adj" fmla="val 5217"/>
+              <a:gd name="adj" fmla="val 4800"/>
             </a:avLst>
           </a:prstGeom>
           <a:solidFill>
@@ -8181,8 +8117,8 @@
         </p:nvSpPr>
         <p:spPr>
           <a:xfrm>
-            <a:off x="9200236" y="2441448"/>
-            <a:ext cx="2104492" cy="502920"/>
+            <a:off x="9177376" y="2404872"/>
+            <a:ext cx="2127352" cy="502920"/>
           </a:xfrm>
           <a:prstGeom prst="rect">
             <a:avLst/>
@@ -8220,8 +8156,8 @@
         </p:nvSpPr>
         <p:spPr>
           <a:xfrm>
-            <a:off x="9200236" y="2971800"/>
-            <a:ext cx="2104492" cy="365760"/>
+            <a:off x="9177376" y="2916936"/>
+            <a:ext cx="2127352" cy="457200"/>
           </a:xfrm>
           <a:prstGeom prst="rect">
             <a:avLst/>
@@ -8259,12 +8195,12 @@
         </p:nvSpPr>
         <p:spPr>
           <a:xfrm>
-            <a:off x="6263640" y="3611880"/>
-            <a:ext cx="2506828" cy="1051560"/>
+            <a:off x="6263640" y="3657600"/>
+            <a:ext cx="2529688" cy="1143000"/>
           </a:xfrm>
           <a:prstGeom prst="roundRect">
             <a:avLst>
-              <a:gd name="adj" fmla="val 5217"/>
+              <a:gd name="adj" fmla="val 4800"/>
             </a:avLst>
           </a:prstGeom>
           <a:solidFill>
@@ -8286,8 +8222,8 @@
         </p:nvSpPr>
         <p:spPr>
           <a:xfrm>
-            <a:off x="6464808" y="3721608"/>
-            <a:ext cx="2104492" cy="502920"/>
+            <a:off x="6464808" y="3730752"/>
+            <a:ext cx="2127352" cy="502920"/>
           </a:xfrm>
           <a:prstGeom prst="rect">
             <a:avLst/>
@@ -8325,8 +8261,8 @@
         </p:nvSpPr>
         <p:spPr>
           <a:xfrm>
-            <a:off x="6464808" y="4251960"/>
-            <a:ext cx="2104492" cy="365760"/>
+            <a:off x="6464808" y="4242816"/>
+            <a:ext cx="2127352" cy="457200"/>
           </a:xfrm>
           <a:prstGeom prst="rect">
             <a:avLst/>
@@ -8364,12 +8300,12 @@
         </p:nvSpPr>
         <p:spPr>
           <a:xfrm>
-            <a:off x="8999068" y="3611880"/>
-            <a:ext cx="2506828" cy="1051560"/>
+            <a:off x="8976208" y="3657600"/>
+            <a:ext cx="2529688" cy="1143000"/>
           </a:xfrm>
           <a:prstGeom prst="roundRect">
             <a:avLst>
-              <a:gd name="adj" fmla="val 5217"/>
+              <a:gd name="adj" fmla="val 4800"/>
             </a:avLst>
           </a:prstGeom>
           <a:solidFill>
@@ -8391,8 +8327,8 @@
         </p:nvSpPr>
         <p:spPr>
           <a:xfrm>
-            <a:off x="9200236" y="3721608"/>
-            <a:ext cx="2104492" cy="502920"/>
+            <a:off x="9177376" y="3730752"/>
+            <a:ext cx="2127352" cy="502920"/>
           </a:xfrm>
           <a:prstGeom prst="rect">
             <a:avLst/>
@@ -8430,8 +8366,8 @@
         </p:nvSpPr>
         <p:spPr>
           <a:xfrm>
-            <a:off x="9200236" y="4251960"/>
-            <a:ext cx="2104492" cy="365760"/>
+            <a:off x="9177376" y="4242816"/>
+            <a:ext cx="2127352" cy="457200"/>
           </a:xfrm>
           <a:prstGeom prst="rect">
             <a:avLst/>
@@ -8469,12 +8405,12 @@
         </p:nvSpPr>
         <p:spPr>
           <a:xfrm>
-            <a:off x="6263640" y="4892040"/>
-            <a:ext cx="2506828" cy="1051560"/>
+            <a:off x="6263640" y="4983480"/>
+            <a:ext cx="2529688" cy="1143000"/>
           </a:xfrm>
           <a:prstGeom prst="roundRect">
             <a:avLst>
-              <a:gd name="adj" fmla="val 5217"/>
+              <a:gd name="adj" fmla="val 4800"/>
             </a:avLst>
           </a:prstGeom>
           <a:solidFill>
@@ -8496,8 +8432,8 @@
         </p:nvSpPr>
         <p:spPr>
           <a:xfrm>
-            <a:off x="6464808" y="5001768"/>
-            <a:ext cx="2104492" cy="502920"/>
+            <a:off x="6464808" y="5056632"/>
+            <a:ext cx="2127352" cy="502920"/>
           </a:xfrm>
           <a:prstGeom prst="rect">
             <a:avLst/>
@@ -8535,8 +8471,8 @@
         </p:nvSpPr>
         <p:spPr>
           <a:xfrm>
-            <a:off x="6464808" y="5532120"/>
-            <a:ext cx="2104492" cy="365760"/>
+            <a:off x="6464808" y="5568696"/>
+            <a:ext cx="2127352" cy="457200"/>
           </a:xfrm>
           <a:prstGeom prst="rect">
             <a:avLst/>
@@ -8574,12 +8510,12 @@
         </p:nvSpPr>
         <p:spPr>
           <a:xfrm>
-            <a:off x="8999068" y="4892040"/>
-            <a:ext cx="2506828" cy="1051560"/>
+            <a:off x="8976208" y="4983480"/>
+            <a:ext cx="2529688" cy="1143000"/>
           </a:xfrm>
           <a:prstGeom prst="roundRect">
             <a:avLst>
-              <a:gd name="adj" fmla="val 5217"/>
+              <a:gd name="adj" fmla="val 4800"/>
             </a:avLst>
           </a:prstGeom>
           <a:solidFill>
@@ -8601,8 +8537,8 @@
         </p:nvSpPr>
         <p:spPr>
           <a:xfrm>
-            <a:off x="9200236" y="5001768"/>
-            <a:ext cx="2104492" cy="502920"/>
+            <a:off x="9177376" y="5056632"/>
+            <a:ext cx="2127352" cy="502920"/>
           </a:xfrm>
           <a:prstGeom prst="rect">
             <a:avLst/>
@@ -8640,8 +8576,8 @@
         </p:nvSpPr>
         <p:spPr>
           <a:xfrm>
-            <a:off x="9200236" y="5532120"/>
-            <a:ext cx="2104492" cy="365760"/>
+            <a:off x="9177376" y="5568696"/>
+            <a:ext cx="2127352" cy="457200"/>
           </a:xfrm>
           <a:prstGeom prst="rect">
             <a:avLst/>
@@ -35099,7 +35035,7 @@
         </p:nvSpPr>
         <p:spPr>
           <a:xfrm>
-            <a:off x="896112" y="2103120"/>
+            <a:off x="896112" y="2057400"/>
             <a:ext cx="7396277" cy="0"/>
           </a:xfrm>
           <a:prstGeom prst="line">
@@ -35122,7 +35058,7 @@
         </p:nvSpPr>
         <p:spPr>
           <a:xfrm>
-            <a:off x="896112" y="4343400"/>
+            <a:off x="896112" y="4160520"/>
             <a:ext cx="7396277" cy="0"/>
           </a:xfrm>
           <a:prstGeom prst="line">
@@ -35145,7 +35081,7 @@
         </p:nvSpPr>
         <p:spPr>
           <a:xfrm>
-            <a:off x="685800" y="1892808"/>
+            <a:off x="685800" y="1847088"/>
             <a:ext cx="420624" cy="420624"/>
           </a:xfrm>
           <a:prstGeom prst="ellipse">
@@ -35165,7 +35101,7 @@
         </p:nvSpPr>
         <p:spPr>
           <a:xfrm>
-            <a:off x="685800" y="1892808"/>
+            <a:off x="685800" y="1847088"/>
             <a:ext cx="420624" cy="420624"/>
           </a:xfrm>
           <a:prstGeom prst="rect">
@@ -35204,12 +35140,12 @@
         </p:nvSpPr>
         <p:spPr>
           <a:xfrm>
-            <a:off x="685800" y="2468880"/>
-            <a:ext cx="3423818" cy="1600200"/>
+            <a:off x="685800" y="2423160"/>
+            <a:ext cx="3423818" cy="1463040"/>
           </a:xfrm>
           <a:prstGeom prst="roundRect">
             <a:avLst>
-              <a:gd name="adj" fmla="val 3429"/>
+              <a:gd name="adj" fmla="val 3750"/>
             </a:avLst>
           </a:prstGeom>
           <a:solidFill>
@@ -35231,7 +35167,7 @@
         </p:nvSpPr>
         <p:spPr>
           <a:xfrm>
-            <a:off x="941832" y="2633472"/>
+            <a:off x="941832" y="2587752"/>
             <a:ext cx="2911754" cy="365760"/>
           </a:xfrm>
           <a:prstGeom prst="rect">
@@ -35270,8 +35206,8 @@
         </p:nvSpPr>
         <p:spPr>
           <a:xfrm>
-            <a:off x="941832" y="3063240"/>
-            <a:ext cx="2911754" cy="914400"/>
+            <a:off x="941832" y="3017520"/>
+            <a:ext cx="2911754" cy="777240"/>
           </a:xfrm>
           <a:prstGeom prst="rect">
             <a:avLst/>
@@ -35309,7 +35245,7 @@
         </p:nvSpPr>
         <p:spPr>
           <a:xfrm>
-            <a:off x="4383938" y="1892808"/>
+            <a:off x="4383938" y="1847088"/>
             <a:ext cx="420624" cy="420624"/>
           </a:xfrm>
           <a:prstGeom prst="ellipse">
@@ -35329,7 +35265,7 @@
         </p:nvSpPr>
         <p:spPr>
           <a:xfrm>
-            <a:off x="4383938" y="1892808"/>
+            <a:off x="4383938" y="1847088"/>
             <a:ext cx="420624" cy="420624"/>
           </a:xfrm>
           <a:prstGeom prst="rect">
@@ -35368,12 +35304,12 @@
         </p:nvSpPr>
         <p:spPr>
           <a:xfrm>
-            <a:off x="4383938" y="2468880"/>
-            <a:ext cx="3423818" cy="1600200"/>
+            <a:off x="4383938" y="2423160"/>
+            <a:ext cx="3423818" cy="1463040"/>
           </a:xfrm>
           <a:prstGeom prst="roundRect">
             <a:avLst>
-              <a:gd name="adj" fmla="val 3429"/>
+              <a:gd name="adj" fmla="val 3750"/>
             </a:avLst>
           </a:prstGeom>
           <a:solidFill>
@@ -35395,7 +35331,7 @@
         </p:nvSpPr>
         <p:spPr>
           <a:xfrm>
-            <a:off x="4639970" y="2633472"/>
+            <a:off x="4639970" y="2587752"/>
             <a:ext cx="2911754" cy="365760"/>
           </a:xfrm>
           <a:prstGeom prst="rect">
@@ -35434,8 +35370,8 @@
         </p:nvSpPr>
         <p:spPr>
           <a:xfrm>
-            <a:off x="4639970" y="3063240"/>
-            <a:ext cx="2911754" cy="914400"/>
+            <a:off x="4639970" y="3017520"/>
+            <a:ext cx="2911754" cy="777240"/>
           </a:xfrm>
           <a:prstGeom prst="rect">
             <a:avLst/>
@@ -35473,7 +35409,7 @@
         </p:nvSpPr>
         <p:spPr>
           <a:xfrm>
-            <a:off x="8082077" y="1892808"/>
+            <a:off x="8082077" y="1847088"/>
             <a:ext cx="420624" cy="420624"/>
           </a:xfrm>
           <a:prstGeom prst="ellipse">
@@ -35493,7 +35429,7 @@
         </p:nvSpPr>
         <p:spPr>
           <a:xfrm>
-            <a:off x="8082077" y="1892808"/>
+            <a:off x="8082077" y="1847088"/>
             <a:ext cx="420624" cy="420624"/>
           </a:xfrm>
           <a:prstGeom prst="rect">
@@ -35532,12 +35468,12 @@
         </p:nvSpPr>
         <p:spPr>
           <a:xfrm>
-            <a:off x="8082077" y="2468880"/>
-            <a:ext cx="3423818" cy="1600200"/>
+            <a:off x="8082077" y="2423160"/>
+            <a:ext cx="3423818" cy="1463040"/>
           </a:xfrm>
           <a:prstGeom prst="roundRect">
             <a:avLst>
-              <a:gd name="adj" fmla="val 3429"/>
+              <a:gd name="adj" fmla="val 3750"/>
             </a:avLst>
           </a:prstGeom>
           <a:solidFill>
@@ -35559,7 +35495,7 @@
         </p:nvSpPr>
         <p:spPr>
           <a:xfrm>
-            <a:off x="8338109" y="2633472"/>
+            <a:off x="8338109" y="2587752"/>
             <a:ext cx="2911754" cy="365760"/>
           </a:xfrm>
           <a:prstGeom prst="rect">
@@ -35598,8 +35534,8 @@
         </p:nvSpPr>
         <p:spPr>
           <a:xfrm>
-            <a:off x="8338109" y="3063240"/>
-            <a:ext cx="2911754" cy="914400"/>
+            <a:off x="8338109" y="3017520"/>
+            <a:ext cx="2911754" cy="777240"/>
           </a:xfrm>
           <a:prstGeom prst="rect">
             <a:avLst/>
@@ -35637,7 +35573,7 @@
         </p:nvSpPr>
         <p:spPr>
           <a:xfrm>
-            <a:off x="685800" y="4133088"/>
+            <a:off x="685800" y="3950208"/>
             <a:ext cx="420624" cy="420624"/>
           </a:xfrm>
           <a:prstGeom prst="ellipse">
@@ -35657,7 +35593,7 @@
         </p:nvSpPr>
         <p:spPr>
           <a:xfrm>
-            <a:off x="685800" y="4133088"/>
+            <a:off x="685800" y="3950208"/>
             <a:ext cx="420624" cy="420624"/>
           </a:xfrm>
           <a:prstGeom prst="rect">
@@ -35696,12 +35632,12 @@
         </p:nvSpPr>
         <p:spPr>
           <a:xfrm>
-            <a:off x="685800" y="4709160"/>
-            <a:ext cx="3423818" cy="1600200"/>
+            <a:off x="685800" y="4526280"/>
+            <a:ext cx="3423818" cy="1463040"/>
           </a:xfrm>
           <a:prstGeom prst="roundRect">
             <a:avLst>
-              <a:gd name="adj" fmla="val 3429"/>
+              <a:gd name="adj" fmla="val 3750"/>
             </a:avLst>
           </a:prstGeom>
           <a:solidFill>
@@ -35723,7 +35659,7 @@
         </p:nvSpPr>
         <p:spPr>
           <a:xfrm>
-            <a:off x="941832" y="4873752"/>
+            <a:off x="941832" y="4690872"/>
             <a:ext cx="2911754" cy="365760"/>
           </a:xfrm>
           <a:prstGeom prst="rect">
@@ -35762,8 +35698,8 @@
         </p:nvSpPr>
         <p:spPr>
           <a:xfrm>
-            <a:off x="941832" y="5303520"/>
-            <a:ext cx="2911754" cy="914400"/>
+            <a:off x="941832" y="5120640"/>
+            <a:ext cx="2911754" cy="777240"/>
           </a:xfrm>
           <a:prstGeom prst="rect">
             <a:avLst/>
@@ -35801,7 +35737,7 @@
         </p:nvSpPr>
         <p:spPr>
           <a:xfrm>
-            <a:off x="4383938" y="4133088"/>
+            <a:off x="4383938" y="3950208"/>
             <a:ext cx="420624" cy="420624"/>
           </a:xfrm>
           <a:prstGeom prst="ellipse">
@@ -35821,7 +35757,7 @@
         </p:nvSpPr>
         <p:spPr>
           <a:xfrm>
-            <a:off x="4383938" y="4133088"/>
+            <a:off x="4383938" y="3950208"/>
             <a:ext cx="420624" cy="420624"/>
           </a:xfrm>
           <a:prstGeom prst="rect">
@@ -35860,12 +35796,12 @@
         </p:nvSpPr>
         <p:spPr>
           <a:xfrm>
-            <a:off x="4383938" y="4709160"/>
-            <a:ext cx="3423818" cy="1600200"/>
+            <a:off x="4383938" y="4526280"/>
+            <a:ext cx="3423818" cy="1463040"/>
           </a:xfrm>
           <a:prstGeom prst="roundRect">
             <a:avLst>
-              <a:gd name="adj" fmla="val 3429"/>
+              <a:gd name="adj" fmla="val 3750"/>
             </a:avLst>
           </a:prstGeom>
           <a:solidFill>
@@ -35887,7 +35823,7 @@
         </p:nvSpPr>
         <p:spPr>
           <a:xfrm>
-            <a:off x="4639970" y="4873752"/>
+            <a:off x="4639970" y="4690872"/>
             <a:ext cx="2911754" cy="365760"/>
           </a:xfrm>
           <a:prstGeom prst="rect">
@@ -35926,8 +35862,8 @@
         </p:nvSpPr>
         <p:spPr>
           <a:xfrm>
-            <a:off x="4639970" y="5303520"/>
-            <a:ext cx="2911754" cy="914400"/>
+            <a:off x="4639970" y="5120640"/>
+            <a:ext cx="2911754" cy="777240"/>
           </a:xfrm>
           <a:prstGeom prst="rect">
             <a:avLst/>
@@ -35965,7 +35901,7 @@
         </p:nvSpPr>
         <p:spPr>
           <a:xfrm>
-            <a:off x="8082077" y="4133088"/>
+            <a:off x="8082077" y="3950208"/>
             <a:ext cx="420624" cy="420624"/>
           </a:xfrm>
           <a:prstGeom prst="ellipse">
@@ -35985,7 +35921,7 @@
         </p:nvSpPr>
         <p:spPr>
           <a:xfrm>
-            <a:off x="8082077" y="4133088"/>
+            <a:off x="8082077" y="3950208"/>
             <a:ext cx="420624" cy="420624"/>
           </a:xfrm>
           <a:prstGeom prst="rect">
@@ -36024,12 +35960,12 @@
         </p:nvSpPr>
         <p:spPr>
           <a:xfrm>
-            <a:off x="8082077" y="4709160"/>
-            <a:ext cx="3423818" cy="1600200"/>
+            <a:off x="8082077" y="4526280"/>
+            <a:ext cx="3423818" cy="1463040"/>
           </a:xfrm>
           <a:prstGeom prst="roundRect">
             <a:avLst>
-              <a:gd name="adj" fmla="val 3429"/>
+              <a:gd name="adj" fmla="val 3750"/>
             </a:avLst>
           </a:prstGeom>
           <a:solidFill>
@@ -36051,7 +35987,7 @@
         </p:nvSpPr>
         <p:spPr>
           <a:xfrm>
-            <a:off x="8338109" y="4873752"/>
+            <a:off x="8338109" y="4690872"/>
             <a:ext cx="2911754" cy="365760"/>
           </a:xfrm>
           <a:prstGeom prst="rect">
@@ -36090,8 +36026,8 @@
         </p:nvSpPr>
         <p:spPr>
           <a:xfrm>
-            <a:off x="8338109" y="5303520"/>
-            <a:ext cx="2911754" cy="914400"/>
+            <a:off x="8338109" y="5120640"/>
+            <a:ext cx="2911754" cy="777240"/>
           </a:xfrm>
           <a:prstGeom prst="rect">
             <a:avLst/>
@@ -36459,24 +36395,7 @@
                 <a:ea typeface="Georgia" pitchFamily="34" charset="-122"/>
                 <a:cs typeface="Georgia" pitchFamily="34" charset="-120"/>
               </a:rPr>
-              <a:t>Vraj </a:t>
-            </a:r>
-            <a:pPr indent="0" marL="0">
-              <a:buNone/>
-            </a:pPr>
-            <a:r>
-              <a:rPr lang="en-US" sz="1600" b="1" dirty="0">
-                <a:solidFill>
-                  <a:srgbClr val="1F2A33"/>
-                </a:solidFill>
-                <a:highlight>
-                  <a:srgbClr val="FFE066"/>
-                </a:highlight>
-                <a:latin typeface="Georgia" pitchFamily="34" charset="0"/>
-                <a:ea typeface="Georgia" pitchFamily="34" charset="-122"/>
-                <a:cs typeface="Georgia" pitchFamily="34" charset="-120"/>
-              </a:rPr>
-              <a:t>[[SURNAME]]</a:t>
+              <a:t>Vraj Panchal</a:t>
             </a:r>
             <a:endParaRPr lang="en-US" sz="1400" dirty="0"/>
           </a:p>
@@ -36569,18 +36488,15 @@
               <a:buNone/>
             </a:pPr>
             <a:r>
-              <a:rPr lang="en-US" sz="1400" b="1" dirty="0">
-                <a:solidFill>
-                  <a:srgbClr val="1F2A33"/>
-                </a:solidFill>
-                <a:highlight>
-                  <a:srgbClr val="FFE066"/>
-                </a:highlight>
+              <a:rPr lang="en-US" sz="1400" dirty="0">
+                <a:solidFill>
+                  <a:srgbClr val="F6F1E7"/>
+                </a:solidFill>
                 <a:latin typeface="Arial" pitchFamily="34" charset="0"/>
                 <a:ea typeface="Arial" pitchFamily="34" charset="-122"/>
                 <a:cs typeface="Arial" pitchFamily="34" charset="-120"/>
               </a:rPr>
-              <a:t>[[GUIDE NAME]]</a:t>
+              <a:t>Prof. Payal Chauhan</a:t>
             </a:r>
             <a:endParaRPr lang="en-US" sz="1400" dirty="0"/>
           </a:p>
@@ -39997,7 +39913,7 @@
                 <a:ea typeface="Arial" pitchFamily="34" charset="-122"/>
                 <a:cs typeface="Arial" pitchFamily="34" charset="-120"/>
               </a:rPr>
-              <a:t>Feasible = visit time + travel time fits the day: 6 h relaxed, 8 h balanced, 10 h packed.</a:t>
+              <a:t>Feasible = visit time + travel time fits the day: 6 h relaxed, 8 h balanced, 10 h packed.</a:t>
             </a:r>
             <a:endParaRPr lang="en-US" sz="1350" dirty="0"/>
           </a:p>

</xml_diff>